<commit_message>
feat(review): keep each finding's problem sentence on one line
The finding layout now has a placeholder under the subtitle, and a sentence longer than 60 characters is rejected so it does not wrap.

Co-authored-by: Cursor <cursoragent@cursor.com>
</commit_message>
<xml_diff>
--- a/assets/review-slide-template.pptx
+++ b/assets/review-slide-template.pptx
@@ -3612,6 +3612,40 @@
             <a:r>
               <a:rPr lang="en-US" dirty="0"/>
               <a:t>Fifth level</a:t>
+            </a:r>
+          </a:p>
+        </p:txBody>
+      </p:sp>
+      <p:sp>
+        <p:nvSpPr>
+          <p:cNvPr id="21" name="Problem Placeholder"/>
+          <p:cNvSpPr>
+            <a:spLocks noGrp="1"/>
+          </p:cNvSpPr>
+          <p:nvPr>
+            <p:ph type="body" sz="quarter" idx="20"/>
+          </p:nvPr>
+        </p:nvSpPr>
+        <p:spPr>
+          <a:xfrm>
+            <a:off x="256032" y="1498283"/>
+            <a:ext cx="6309360" cy="182880"/>
+          </a:xfrm>
+        </p:spPr>
+        <p:txBody>
+          <a:bodyPr wrap="none" lIns="0" tIns="0" rIns="0" bIns="0" anchor="ctr"/>
+          <a:lstStyle/>
+          <a:p>
+            <a:pPr>
+              <a:buNone/>
+            </a:pPr>
+            <a:r>
+              <a:rPr lang="en-US" sz="1400" dirty="0">
+                <a:latin typeface="Arial"/>
+                <a:ea typeface="Arial"/>
+                <a:cs typeface="Arial"/>
+              </a:rPr>
+              <a:t/>
             </a:r>
           </a:p>
         </p:txBody>
@@ -8196,6 +8230,40 @@
           </a:xfrm>
         </p:spPr>
       </p:pic>
+      <p:sp>
+        <p:nvSpPr>
+          <p:cNvPr id="21" name="Problem"/>
+          <p:cNvSpPr>
+            <a:spLocks noGrp="1"/>
+          </p:cNvSpPr>
+          <p:nvPr>
+            <p:ph type="body" sz="quarter" idx="20"/>
+          </p:nvPr>
+        </p:nvSpPr>
+        <p:spPr>
+          <a:xfrm>
+            <a:off x="256032" y="1498283"/>
+            <a:ext cx="6309360" cy="182880"/>
+          </a:xfrm>
+        </p:spPr>
+        <p:txBody>
+          <a:bodyPr wrap="none" lIns="0" tIns="0" rIns="0" bIns="0" anchor="ctr"/>
+          <a:lstStyle/>
+          <a:p>
+            <a:pPr>
+              <a:buNone/>
+            </a:pPr>
+            <a:r>
+              <a:rPr lang="en-US" sz="1400" dirty="0">
+                <a:latin typeface="Arial"/>
+                <a:ea typeface="Arial"/>
+                <a:cs typeface="Arial"/>
+              </a:rPr>
+              <a:t>{{PROBLEM}}</a:t>
+            </a:r>
+          </a:p>
+        </p:txBody>
+      </p:sp>
     </p:spTree>
   </p:cSld>
   <p:clrMapOvr>

</xml_diff>

<commit_message>
feat(review): color the existing subtitle by finding severity
The one-line summary stays on the subtitle already under the eyebrow, and that line turns dark red, orange, blue, or green without printing the severity word.

Co-authored-by: Cursor <cursoragent@cursor.com>
</commit_message>
<xml_diff>
--- a/assets/review-slide-template.pptx
+++ b/assets/review-slide-template.pptx
@@ -3291,7 +3291,7 @@
           </a:xfrm>
         </p:spPr>
         <p:txBody>
-          <a:bodyPr tIns="0">
+          <a:bodyPr wrap="none" tIns="0" lIns="0" rIns="0" bIns="0">
             <a:noAutofit/>
           </a:bodyPr>
           <a:lstStyle>
@@ -3612,40 +3612,6 @@
             <a:r>
               <a:rPr lang="en-US" dirty="0"/>
               <a:t>Fifth level</a:t>
-            </a:r>
-          </a:p>
-        </p:txBody>
-      </p:sp>
-      <p:sp>
-        <p:nvSpPr>
-          <p:cNvPr id="21" name="Problem Placeholder"/>
-          <p:cNvSpPr>
-            <a:spLocks noGrp="1"/>
-          </p:cNvSpPr>
-          <p:nvPr>
-            <p:ph type="body" sz="quarter" idx="20"/>
-          </p:nvPr>
-        </p:nvSpPr>
-        <p:spPr>
-          <a:xfrm>
-            <a:off x="256032" y="1498283"/>
-            <a:ext cx="6309360" cy="182880"/>
-          </a:xfrm>
-        </p:spPr>
-        <p:txBody>
-          <a:bodyPr wrap="none" lIns="0" tIns="0" rIns="0" bIns="0" anchor="ctr"/>
-          <a:lstStyle/>
-          <a:p>
-            <a:pPr>
-              <a:buNone/>
-            </a:pPr>
-            <a:r>
-              <a:rPr lang="en-US" sz="1400" dirty="0">
-                <a:latin typeface="Arial"/>
-                <a:ea typeface="Arial"/>
-                <a:cs typeface="Arial"/>
-              </a:rPr>
-              <a:t/>
             </a:r>
           </a:p>
         </p:txBody>
@@ -8140,11 +8106,18 @@
           </a:xfrm>
         </p:spPr>
         <p:txBody>
-          <a:bodyPr/>
+          <a:bodyPr wrap="none" lIns="0" tIns="0" rIns="0" bIns="0" anchor="ctr"/>
           <a:lstStyle/>
           <a:p>
             <a:r>
-              <a:rPr lang="en-US" dirty="0"/>
+              <a:rPr lang="en-US" sz="1800" b="1" dirty="0">
+                <a:solidFill>
+                  <a:srgbClr val="1A1A1A"/>
+                </a:solidFill>
+                <a:latin typeface="Arial"/>
+                <a:ea typeface="Arial"/>
+                <a:cs typeface="Arial"/>
+              </a:rPr>
               <a:t>{{SUBTITLE}}</a:t>
             </a:r>
           </a:p>
@@ -8230,40 +8203,6 @@
           </a:xfrm>
         </p:spPr>
       </p:pic>
-      <p:sp>
-        <p:nvSpPr>
-          <p:cNvPr id="21" name="Problem"/>
-          <p:cNvSpPr>
-            <a:spLocks noGrp="1"/>
-          </p:cNvSpPr>
-          <p:nvPr>
-            <p:ph type="body" sz="quarter" idx="20"/>
-          </p:nvPr>
-        </p:nvSpPr>
-        <p:spPr>
-          <a:xfrm>
-            <a:off x="256032" y="1498283"/>
-            <a:ext cx="6309360" cy="182880"/>
-          </a:xfrm>
-        </p:spPr>
-        <p:txBody>
-          <a:bodyPr wrap="none" lIns="0" tIns="0" rIns="0" bIns="0" anchor="ctr"/>
-          <a:lstStyle/>
-          <a:p>
-            <a:pPr>
-              <a:buNone/>
-            </a:pPr>
-            <a:r>
-              <a:rPr lang="en-US" sz="1400" dirty="0">
-                <a:latin typeface="Arial"/>
-                <a:ea typeface="Arial"/>
-                <a:cs typeface="Arial"/>
-              </a:rPr>
-              <a:t>{{PROBLEM}}</a:t>
-            </a:r>
-          </a:p>
-        </p:txBody>
-      </p:sp>
     </p:spTree>
   </p:cSld>
   <p:clrMapOvr>

</xml_diff>